<commit_message>
Updates for link rot
</commit_message>
<xml_diff>
--- a/rep-workflows.pptx
+++ b/rep-workflows.pptx
@@ -290,7 +290,7 @@
           <a:p>
             <a:fld id="{0B842F42-2CE9-4E35-95C1-410DC08A50B1}" type="datetimeFigureOut">
               <a:rPr lang="en-US" smtClean="0"/>
-              <a:t>6/17/2024</a:t>
+              <a:t>8/2/2026</a:t>
             </a:fld>
             <a:endParaRPr lang="en-US"/>
           </a:p>
@@ -455,7 +455,7 @@
           <a:p>
             <a:fld id="{6F282904-F315-4730-8D91-37D99E141A6F}" type="datetimeFigureOut">
               <a:rPr lang="en-US" smtClean="0"/>
-              <a:t>6/17/2024</a:t>
+              <a:t>8/2/2026</a:t>
             </a:fld>
             <a:endParaRPr lang="en-US"/>
           </a:p>
@@ -15147,13 +15147,7 @@
               <a:rPr lang="en-US" sz="1400" dirty="0">
                 <a:hlinkClick r:id="rId6"/>
               </a:rPr>
-              <a:t>https://</a:t>
-            </a:r>
-            <a:r>
-              <a:rPr lang="en-US" sz="1400" dirty="0" err="1">
-                <a:hlinkClick r:id="rId6"/>
-              </a:rPr>
-              <a:t>www.covalent.xyz</a:t>
+              <a:t>https://www.datarobot.com/product/covalent/</a:t>
             </a:r>
             <a:endParaRPr lang="en-US" sz="1400" dirty="0"/>
           </a:p>
@@ -15166,13 +15160,7 @@
               <a:rPr lang="en-US" sz="1400" dirty="0">
                 <a:hlinkClick r:id="rId7"/>
               </a:rPr>
-              <a:t>http://</a:t>
-            </a:r>
-            <a:r>
-              <a:rPr lang="en-US" sz="1400" dirty="0" err="1">
-                <a:hlinkClick r:id="rId7"/>
-              </a:rPr>
-              <a:t>cromwell.readthedocs.io</a:t>
+              <a:t>http://cromwell.readthedocs.io</a:t>
             </a:r>
             <a:endParaRPr lang="en-US" sz="1400" dirty="0"/>
           </a:p>
@@ -23150,6 +23138,12 @@
 </file>
 
 <file path=customXml/item1.xml><?xml version="1.0" encoding="utf-8"?>
+<p:properties xmlns:p="http://schemas.microsoft.com/office/2006/metadata/properties" xmlns:xsi="http://www.w3.org/2001/XMLSchema-instance" xmlns:pc="http://schemas.microsoft.com/office/infopath/2007/PartnerControls">
+  <documentManagement/>
+</p:properties>
+</file>
+
+<file path=customXml/item2.xml><?xml version="1.0" encoding="utf-8"?>
 <ct:contentTypeSchema xmlns:ct="http://schemas.microsoft.com/office/2006/metadata/contentType" xmlns:ma="http://schemas.microsoft.com/office/2006/metadata/properties/metaAttributes" ct:_="" ma:_="" ma:contentTypeName="Document" ma:contentTypeID="0x010100565464437F680748A68B85EB6594EA7D" ma:contentTypeVersion="0" ma:contentTypeDescription="Create a new document." ma:contentTypeScope="" ma:versionID="fe3f4dd58d5914c51cfc6deaa8ad845c">
   <xsd:schema xmlns:xsd="http://www.w3.org/2001/XMLSchema" xmlns:p="http://schemas.microsoft.com/office/2006/metadata/properties" targetNamespace="http://schemas.microsoft.com/office/2006/metadata/properties" ma:root="true" ma:fieldsID="4aeb20c0e3442673af7ee10786458764">
     <xsd:element name="properties">
@@ -23198,12 +23192,6 @@
 </ct:contentTypeSchema>
 </file>
 
-<file path=customXml/item2.xml><?xml version="1.0" encoding="utf-8"?>
-<p:properties xmlns:p="http://schemas.microsoft.com/office/2006/metadata/properties" xmlns:xsi="http://www.w3.org/2001/XMLSchema-instance" xmlns:pc="http://schemas.microsoft.com/office/infopath/2007/PartnerControls">
-  <documentManagement/>
-</p:properties>
-</file>
-
 <file path=customXml/item3.xml><?xml version="1.0" encoding="utf-8"?>
 <?mso-contentType ?>
 <FormTemplates xmlns="http://schemas.microsoft.com/sharepoint/v3/contenttype/forms">
@@ -23214,6 +23202,21 @@
 </file>
 
 <file path=customXml/itemProps1.xml><?xml version="1.0" encoding="utf-8"?>
+<ds:datastoreItem xmlns:ds="http://schemas.openxmlformats.org/officeDocument/2006/customXml" ds:itemID="{A50EC660-24D0-43A0-AE5E-E274115E726B}">
+  <ds:schemaRefs>
+    <ds:schemaRef ds:uri="http://purl.org/dc/elements/1.1/"/>
+    <ds:schemaRef ds:uri="http://schemas.microsoft.com/office/2006/metadata/properties"/>
+    <ds:schemaRef ds:uri="http://purl.org/dc/terms/"/>
+    <ds:schemaRef ds:uri="http://schemas.openxmlformats.org/package/2006/metadata/core-properties"/>
+    <ds:schemaRef ds:uri="http://schemas.microsoft.com/office/2006/documentManagement/types"/>
+    <ds:schemaRef ds:uri="http://www.w3.org/XML/1998/namespace"/>
+    <ds:schemaRef ds:uri="http://purl.org/dc/dcmitype/"/>
+    <ds:schemaRef ds:uri="http://schemas.microsoft.com/office/infopath/2007/PartnerControls"/>
+  </ds:schemaRefs>
+</ds:datastoreItem>
+</file>
+
+<file path=customXml/itemProps2.xml><?xml version="1.0" encoding="utf-8"?>
 <ds:datastoreItem xmlns:ds="http://schemas.openxmlformats.org/officeDocument/2006/customXml" ds:itemID="{E8DB7DEB-074E-4EE8-9B6E-FD277323109C}">
   <ds:schemaRefs>
     <ds:schemaRef ds:uri="http://schemas.microsoft.com/office/2006/metadata/contentType"/>
@@ -23228,21 +23231,6 @@
 </ds:datastoreItem>
 </file>
 
-<file path=customXml/itemProps2.xml><?xml version="1.0" encoding="utf-8"?>
-<ds:datastoreItem xmlns:ds="http://schemas.openxmlformats.org/officeDocument/2006/customXml" ds:itemID="{A50EC660-24D0-43A0-AE5E-E274115E726B}">
-  <ds:schemaRefs>
-    <ds:schemaRef ds:uri="http://purl.org/dc/elements/1.1/"/>
-    <ds:schemaRef ds:uri="http://schemas.microsoft.com/office/2006/metadata/properties"/>
-    <ds:schemaRef ds:uri="http://purl.org/dc/terms/"/>
-    <ds:schemaRef ds:uri="http://schemas.openxmlformats.org/package/2006/metadata/core-properties"/>
-    <ds:schemaRef ds:uri="http://schemas.microsoft.com/office/2006/documentManagement/types"/>
-    <ds:schemaRef ds:uri="http://www.w3.org/XML/1998/namespace"/>
-    <ds:schemaRef ds:uri="http://purl.org/dc/dcmitype/"/>
-    <ds:schemaRef ds:uri="http://schemas.microsoft.com/office/infopath/2007/PartnerControls"/>
-  </ds:schemaRefs>
-</ds:datastoreItem>
-</file>
-
 <file path=customXml/itemProps3.xml><?xml version="1.0" encoding="utf-8"?>
 <ds:datastoreItem xmlns:ds="http://schemas.openxmlformats.org/officeDocument/2006/customXml" ds:itemID="{19E20559-B232-4371-8690-E3D8007EDB82}">
   <ds:schemaRefs>

</xml_diff>